<commit_message>
Fit the encoder-reuse line on slide 4
</commit_message>
<xml_diff>
--- a/meeting/SourceDepth_weekly_v9.pptx
+++ b/meeting/SourceDepth_weekly_v9.pptx
@@ -10314,8 +10314,8 @@
         </p:nvSpPr>
         <p:spPr>
           <a:xfrm>
-            <a:off x="777240" y="4334256"/>
-            <a:ext cx="10698480" cy="256032"/>
+            <a:off x="777240" y="4315968"/>
+            <a:ext cx="10698480" cy="292608"/>
           </a:xfrm>
           <a:prstGeom prst="rect">
             <a:avLst/>
@@ -10331,7 +10331,7 @@
               <a:buNone/>
             </a:pPr>
             <a:r>
-              <a:rPr lang="en-US" sz="1050" dirty="0">
+              <a:rPr lang="en-US" sz="1000" dirty="0">
                 <a:solidFill>
                   <a:srgbClr val="1F3B57"/>
                 </a:solidFill>
@@ -10339,9 +10339,9 @@
                 <a:ea typeface="Arial" pitchFamily="34" charset="-122"/>
                 <a:cs typeface="Arial" pitchFamily="34" charset="-120"/>
               </a:rPr>
-              <a:t>그리고 판별과 개입에 같은 수단(attention 마스크)을 쓰기 때문에, 이미지 인코딩(비용의 66%)을 N+1회 전부 재사용할 수 있습니다 — 픽셀을 바꾸는 방식은 매번 다시 인코딩해야 합니다.</a:t>
+              <a:t>판별과 개입에 같은 수단(attention 마스크)을 쓰므로 이미지 인코딩(비용의 66%)을 N+1회 재사용할 수 있습니다. 픽셀을 바꾸면 매번 재인코딩해야 합니다.</a:t>
             </a:r>
-            <a:endParaRPr lang="en-US" sz="1050" dirty="0"/>
+            <a:endParaRPr lang="en-US" sz="1000" dirty="0"/>
           </a:p>
         </p:txBody>
       </p:sp>

</xml_diff>